<commit_message>
Ajusta alturas dos cards do VPC
Co-Authored-By: Claude Fable 5.1 <noreply@anthropic.com>
Claude-Session: https://claude.ai/code/session_01PdsmYxSMPP7HSkDtR6tasn
</commit_message>
<xml_diff>
--- a/apresentacao/cora-exercicio-aula.pptx
+++ b/apresentacao/cora-exercicio-aula.pptx
@@ -113,7 +113,7 @@
   <p:extLst>
     <p:ext uri="{521415D9-36F7-43E2-AB2F-B90AF26B5E84}">
       <p14:sectionLst xmlns:p14="http://schemas.microsoft.com/office/powerpoint/2010/main">
-        <p14:section name="Exercício · Aula Produto 2" id="{4632fe36-c761-0884-b59d-9859bfe27ac6}">
+        <p14:section name="Exercício · Aula Produto 2" id="{89ad9d68-6864-22a0-fc33-44386680c674}">
           <p14:sldIdLst>
             <p14:sldId id="256"/>
             <p14:sldId id="257"/>
@@ -5116,12 +5116,12 @@
         </p:nvSpPr>
         <p:spPr>
           <a:xfrm>
-            <a:off x="548640" y="1572768"/>
-            <a:ext cx="3840480" cy="877824"/>
+            <a:off x="548640" y="1554480"/>
+            <a:ext cx="3840480" cy="941832"/>
           </a:xfrm>
           <a:prstGeom prst="roundRect">
             <a:avLst>
-              <a:gd name="adj" fmla="val 16667"/>
+              <a:gd name="adj" fmla="val 15534"/>
             </a:avLst>
           </a:prstGeom>
           <a:solidFill>
@@ -5150,7 +5150,7 @@
         </p:nvSpPr>
         <p:spPr>
           <a:xfrm>
-            <a:off x="713232" y="1664208"/>
+            <a:off x="713232" y="1645920"/>
             <a:ext cx="3511296" cy="182880"/>
           </a:xfrm>
           <a:prstGeom prst="rect">
@@ -5186,8 +5186,8 @@
         </p:nvSpPr>
         <p:spPr>
           <a:xfrm>
-            <a:off x="713232" y="1856232"/>
-            <a:ext cx="3511296" cy="548640"/>
+            <a:off x="713232" y="1837944"/>
+            <a:ext cx="3511296" cy="612648"/>
           </a:xfrm>
           <a:prstGeom prst="rect">
             <a:avLst/>
@@ -5262,12 +5262,12 @@
         </p:nvSpPr>
         <p:spPr>
           <a:xfrm>
-            <a:off x="4754880" y="1572768"/>
-            <a:ext cx="3840480" cy="877824"/>
+            <a:off x="4754880" y="1554480"/>
+            <a:ext cx="3840480" cy="941832"/>
           </a:xfrm>
           <a:prstGeom prst="roundRect">
             <a:avLst>
-              <a:gd name="adj" fmla="val 16667"/>
+              <a:gd name="adj" fmla="val 15534"/>
             </a:avLst>
           </a:prstGeom>
           <a:solidFill>
@@ -5296,7 +5296,7 @@
         </p:nvSpPr>
         <p:spPr>
           <a:xfrm>
-            <a:off x="4919472" y="1664208"/>
+            <a:off x="4919472" y="1645920"/>
             <a:ext cx="3511296" cy="182880"/>
           </a:xfrm>
           <a:prstGeom prst="rect">
@@ -5332,8 +5332,8 @@
         </p:nvSpPr>
         <p:spPr>
           <a:xfrm>
-            <a:off x="4919472" y="1856232"/>
-            <a:ext cx="3511296" cy="548640"/>
+            <a:off x="4919472" y="1837944"/>
+            <a:ext cx="3511296" cy="612648"/>
           </a:xfrm>
           <a:prstGeom prst="rect">
             <a:avLst/>
@@ -5444,12 +5444,12 @@
         </p:nvSpPr>
         <p:spPr>
           <a:xfrm>
-            <a:off x="548640" y="2505456"/>
-            <a:ext cx="3840480" cy="941832"/>
+            <a:off x="548640" y="2542032"/>
+            <a:ext cx="3840480" cy="1005840"/>
           </a:xfrm>
           <a:prstGeom prst="roundRect">
             <a:avLst>
-              <a:gd name="adj" fmla="val 15534"/>
+              <a:gd name="adj" fmla="val 14545"/>
             </a:avLst>
           </a:prstGeom>
           <a:solidFill>
@@ -5478,7 +5478,7 @@
         </p:nvSpPr>
         <p:spPr>
           <a:xfrm>
-            <a:off x="713232" y="2596896"/>
+            <a:off x="713232" y="2633472"/>
             <a:ext cx="3511296" cy="182880"/>
           </a:xfrm>
           <a:prstGeom prst="rect">
@@ -5514,8 +5514,8 @@
         </p:nvSpPr>
         <p:spPr>
           <a:xfrm>
-            <a:off x="713232" y="2788920"/>
-            <a:ext cx="3511296" cy="612648"/>
+            <a:off x="713232" y="2825496"/>
+            <a:ext cx="3511296" cy="676656"/>
           </a:xfrm>
           <a:prstGeom prst="rect">
             <a:avLst/>
@@ -5608,12 +5608,12 @@
         </p:nvSpPr>
         <p:spPr>
           <a:xfrm>
-            <a:off x="4754880" y="2505456"/>
-            <a:ext cx="3840480" cy="941832"/>
+            <a:off x="4754880" y="2542032"/>
+            <a:ext cx="3840480" cy="1005840"/>
           </a:xfrm>
           <a:prstGeom prst="roundRect">
             <a:avLst>
-              <a:gd name="adj" fmla="val 15534"/>
+              <a:gd name="adj" fmla="val 14545"/>
             </a:avLst>
           </a:prstGeom>
           <a:solidFill>
@@ -5642,7 +5642,7 @@
         </p:nvSpPr>
         <p:spPr>
           <a:xfrm>
-            <a:off x="4919472" y="2596896"/>
+            <a:off x="4919472" y="2633472"/>
             <a:ext cx="3511296" cy="182880"/>
           </a:xfrm>
           <a:prstGeom prst="rect">
@@ -5678,8 +5678,8 @@
         </p:nvSpPr>
         <p:spPr>
           <a:xfrm>
-            <a:off x="4919472" y="2788920"/>
-            <a:ext cx="3511296" cy="612648"/>
+            <a:off x="4919472" y="2825496"/>
+            <a:ext cx="3511296" cy="676656"/>
           </a:xfrm>
           <a:prstGeom prst="rect">
             <a:avLst/>
@@ -5790,12 +5790,12 @@
         </p:nvSpPr>
         <p:spPr>
           <a:xfrm>
-            <a:off x="548640" y="3502152"/>
-            <a:ext cx="3840480" cy="1152144"/>
+            <a:off x="548640" y="3593592"/>
+            <a:ext cx="3840480" cy="1106424"/>
           </a:xfrm>
           <a:prstGeom prst="roundRect">
             <a:avLst>
-              <a:gd name="adj" fmla="val 12698"/>
+              <a:gd name="adj" fmla="val 13223"/>
             </a:avLst>
           </a:prstGeom>
           <a:solidFill>
@@ -5824,7 +5824,7 @@
         </p:nvSpPr>
         <p:spPr>
           <a:xfrm>
-            <a:off x="713232" y="3593592"/>
+            <a:off x="713232" y="3685032"/>
             <a:ext cx="3511296" cy="182880"/>
           </a:xfrm>
           <a:prstGeom prst="rect">
@@ -5860,8 +5860,8 @@
         </p:nvSpPr>
         <p:spPr>
           <a:xfrm>
-            <a:off x="713232" y="3785616"/>
-            <a:ext cx="3511296" cy="822960"/>
+            <a:off x="713232" y="3877056"/>
+            <a:ext cx="3511296" cy="777240"/>
           </a:xfrm>
           <a:prstGeom prst="rect">
             <a:avLst/>
@@ -5990,12 +5990,12 @@
         </p:nvSpPr>
         <p:spPr>
           <a:xfrm>
-            <a:off x="4754880" y="3502152"/>
-            <a:ext cx="3840480" cy="1152144"/>
+            <a:off x="4754880" y="3593592"/>
+            <a:ext cx="3840480" cy="1106424"/>
           </a:xfrm>
           <a:prstGeom prst="roundRect">
             <a:avLst>
-              <a:gd name="adj" fmla="val 12698"/>
+              <a:gd name="adj" fmla="val 13223"/>
             </a:avLst>
           </a:prstGeom>
           <a:solidFill>
@@ -6024,7 +6024,7 @@
         </p:nvSpPr>
         <p:spPr>
           <a:xfrm>
-            <a:off x="4919472" y="3593592"/>
+            <a:off x="4919472" y="3685032"/>
             <a:ext cx="3511296" cy="182880"/>
           </a:xfrm>
           <a:prstGeom prst="rect">
@@ -6060,8 +6060,8 @@
         </p:nvSpPr>
         <p:spPr>
           <a:xfrm>
-            <a:off x="4919472" y="3785616"/>
-            <a:ext cx="3511296" cy="822960"/>
+            <a:off x="4919472" y="3877056"/>
+            <a:ext cx="3511296" cy="777240"/>
           </a:xfrm>
           <a:prstGeom prst="rect">
             <a:avLst/>

</xml_diff>